<commit_message>
add more content in rdbms
</commit_message>
<xml_diff>
--- a/rdbms/SQL Plus/RDBMS_Sem-1/Practical Topic PPTs/Exception Handling.pptx
+++ b/rdbms/SQL Plus/RDBMS_Sem-1/Practical Topic PPTs/Exception Handling.pptx
@@ -143,7 +143,7 @@
           <p:cNvPr id="2" name="Title 1">
             <a:extLst>
               <a:ext uri="{FF2B5EF4-FFF2-40B4-BE49-F238E27FC236}">
-                <a16:creationId xmlns:a16="http://schemas.microsoft.com/office/drawing/2014/main" xmlns="" id="{2B720107-3FCE-46C8-9F69-B1FBFCA688F0}"/>
+                <a16:creationId xmlns="" xmlns:a16="http://schemas.microsoft.com/office/drawing/2014/main" id="{2B720107-3FCE-46C8-9F69-B1FBFCA688F0}"/>
               </a:ext>
             </a:extLst>
           </p:cNvPr>
@@ -181,7 +181,7 @@
           <p:cNvPr id="3" name="Subtitle 2">
             <a:extLst>
               <a:ext uri="{FF2B5EF4-FFF2-40B4-BE49-F238E27FC236}">
-                <a16:creationId xmlns:a16="http://schemas.microsoft.com/office/drawing/2014/main" xmlns="" id="{0AB9A19B-A765-4F2F-94C1-4760A3571570}"/>
+                <a16:creationId xmlns="" xmlns:a16="http://schemas.microsoft.com/office/drawing/2014/main" id="{0AB9A19B-A765-4F2F-94C1-4760A3571570}"/>
               </a:ext>
             </a:extLst>
           </p:cNvPr>
@@ -252,7 +252,7 @@
           <p:cNvPr id="4" name="Date Placeholder 3">
             <a:extLst>
               <a:ext uri="{FF2B5EF4-FFF2-40B4-BE49-F238E27FC236}">
-                <a16:creationId xmlns:a16="http://schemas.microsoft.com/office/drawing/2014/main" xmlns="" id="{B9933038-90E8-46E4-B168-954149CC80D8}"/>
+                <a16:creationId xmlns="" xmlns:a16="http://schemas.microsoft.com/office/drawing/2014/main" id="{B9933038-90E8-46E4-B168-954149CC80D8}"/>
               </a:ext>
             </a:extLst>
           </p:cNvPr>
@@ -270,7 +270,7 @@
           <a:p>
             <a:fld id="{B8663ADC-7E29-4153-BDB6-70B1CEFC7B31}" type="datetimeFigureOut">
               <a:rPr lang="en-IN" smtClean="0"/>
-              <a:t>04-09-2023</a:t>
+              <a:t>17-11-2025</a:t>
             </a:fld>
             <a:endParaRPr lang="en-IN"/>
           </a:p>
@@ -281,7 +281,7 @@
           <p:cNvPr id="5" name="Footer Placeholder 4">
             <a:extLst>
               <a:ext uri="{FF2B5EF4-FFF2-40B4-BE49-F238E27FC236}">
-                <a16:creationId xmlns:a16="http://schemas.microsoft.com/office/drawing/2014/main" xmlns="" id="{027B1E93-A7C6-4CF8-ACB9-2AD4C2D7401B}"/>
+                <a16:creationId xmlns="" xmlns:a16="http://schemas.microsoft.com/office/drawing/2014/main" id="{027B1E93-A7C6-4CF8-ACB9-2AD4C2D7401B}"/>
               </a:ext>
             </a:extLst>
           </p:cNvPr>
@@ -306,7 +306,7 @@
           <p:cNvPr id="6" name="Slide Number Placeholder 5">
             <a:extLst>
               <a:ext uri="{FF2B5EF4-FFF2-40B4-BE49-F238E27FC236}">
-                <a16:creationId xmlns:a16="http://schemas.microsoft.com/office/drawing/2014/main" xmlns="" id="{8D0A930F-E1D5-4020-BED6-1FE603A9C297}"/>
+                <a16:creationId xmlns="" xmlns:a16="http://schemas.microsoft.com/office/drawing/2014/main" id="{8D0A930F-E1D5-4020-BED6-1FE603A9C297}"/>
               </a:ext>
             </a:extLst>
           </p:cNvPr>
@@ -365,7 +365,7 @@
           <p:cNvPr id="2" name="Title 1">
             <a:extLst>
               <a:ext uri="{FF2B5EF4-FFF2-40B4-BE49-F238E27FC236}">
-                <a16:creationId xmlns:a16="http://schemas.microsoft.com/office/drawing/2014/main" xmlns="" id="{4568E0AD-071B-4F32-88E4-393604698635}"/>
+                <a16:creationId xmlns="" xmlns:a16="http://schemas.microsoft.com/office/drawing/2014/main" id="{4568E0AD-071B-4F32-88E4-393604698635}"/>
               </a:ext>
             </a:extLst>
           </p:cNvPr>
@@ -394,7 +394,7 @@
           <p:cNvPr id="3" name="Vertical Text Placeholder 2">
             <a:extLst>
               <a:ext uri="{FF2B5EF4-FFF2-40B4-BE49-F238E27FC236}">
-                <a16:creationId xmlns:a16="http://schemas.microsoft.com/office/drawing/2014/main" xmlns="" id="{4DA818DB-5A75-4EA4-94F0-A94623579362}"/>
+                <a16:creationId xmlns="" xmlns:a16="http://schemas.microsoft.com/office/drawing/2014/main" id="{4DA818DB-5A75-4EA4-94F0-A94623579362}"/>
               </a:ext>
             </a:extLst>
           </p:cNvPr>
@@ -452,7 +452,7 @@
           <p:cNvPr id="4" name="Date Placeholder 3">
             <a:extLst>
               <a:ext uri="{FF2B5EF4-FFF2-40B4-BE49-F238E27FC236}">
-                <a16:creationId xmlns:a16="http://schemas.microsoft.com/office/drawing/2014/main" xmlns="" id="{EF0CCB6E-969C-41AF-8081-8F402FD46F05}"/>
+                <a16:creationId xmlns="" xmlns:a16="http://schemas.microsoft.com/office/drawing/2014/main" id="{EF0CCB6E-969C-41AF-8081-8F402FD46F05}"/>
               </a:ext>
             </a:extLst>
           </p:cNvPr>
@@ -470,7 +470,7 @@
           <a:p>
             <a:fld id="{B8663ADC-7E29-4153-BDB6-70B1CEFC7B31}" type="datetimeFigureOut">
               <a:rPr lang="en-IN" smtClean="0"/>
-              <a:t>04-09-2023</a:t>
+              <a:t>17-11-2025</a:t>
             </a:fld>
             <a:endParaRPr lang="en-IN"/>
           </a:p>
@@ -481,7 +481,7 @@
           <p:cNvPr id="5" name="Footer Placeholder 4">
             <a:extLst>
               <a:ext uri="{FF2B5EF4-FFF2-40B4-BE49-F238E27FC236}">
-                <a16:creationId xmlns:a16="http://schemas.microsoft.com/office/drawing/2014/main" xmlns="" id="{72C2D740-2F31-4994-984C-0BF182383069}"/>
+                <a16:creationId xmlns="" xmlns:a16="http://schemas.microsoft.com/office/drawing/2014/main" id="{72C2D740-2F31-4994-984C-0BF182383069}"/>
               </a:ext>
             </a:extLst>
           </p:cNvPr>
@@ -506,7 +506,7 @@
           <p:cNvPr id="6" name="Slide Number Placeholder 5">
             <a:extLst>
               <a:ext uri="{FF2B5EF4-FFF2-40B4-BE49-F238E27FC236}">
-                <a16:creationId xmlns:a16="http://schemas.microsoft.com/office/drawing/2014/main" xmlns="" id="{F27C670F-9D9A-4B7D-A54A-622B021C7D29}"/>
+                <a16:creationId xmlns="" xmlns:a16="http://schemas.microsoft.com/office/drawing/2014/main" id="{F27C670F-9D9A-4B7D-A54A-622B021C7D29}"/>
               </a:ext>
             </a:extLst>
           </p:cNvPr>
@@ -565,7 +565,7 @@
           <p:cNvPr id="2" name="Vertical Title 1">
             <a:extLst>
               <a:ext uri="{FF2B5EF4-FFF2-40B4-BE49-F238E27FC236}">
-                <a16:creationId xmlns:a16="http://schemas.microsoft.com/office/drawing/2014/main" xmlns="" id="{7BD95762-F080-4275-8F7B-6AFB4D76E35D}"/>
+                <a16:creationId xmlns="" xmlns:a16="http://schemas.microsoft.com/office/drawing/2014/main" id="{7BD95762-F080-4275-8F7B-6AFB4D76E35D}"/>
               </a:ext>
             </a:extLst>
           </p:cNvPr>
@@ -599,7 +599,7 @@
           <p:cNvPr id="3" name="Vertical Text Placeholder 2">
             <a:extLst>
               <a:ext uri="{FF2B5EF4-FFF2-40B4-BE49-F238E27FC236}">
-                <a16:creationId xmlns:a16="http://schemas.microsoft.com/office/drawing/2014/main" xmlns="" id="{96C86EE5-9C2D-42C8-957E-6F57A4787C7D}"/>
+                <a16:creationId xmlns="" xmlns:a16="http://schemas.microsoft.com/office/drawing/2014/main" id="{96C86EE5-9C2D-42C8-957E-6F57A4787C7D}"/>
               </a:ext>
             </a:extLst>
           </p:cNvPr>
@@ -662,7 +662,7 @@
           <p:cNvPr id="4" name="Date Placeholder 3">
             <a:extLst>
               <a:ext uri="{FF2B5EF4-FFF2-40B4-BE49-F238E27FC236}">
-                <a16:creationId xmlns:a16="http://schemas.microsoft.com/office/drawing/2014/main" xmlns="" id="{5B18B2E0-1D2F-4DDB-A733-5C55B8A4D374}"/>
+                <a16:creationId xmlns="" xmlns:a16="http://schemas.microsoft.com/office/drawing/2014/main" id="{5B18B2E0-1D2F-4DDB-A733-5C55B8A4D374}"/>
               </a:ext>
             </a:extLst>
           </p:cNvPr>
@@ -680,7 +680,7 @@
           <a:p>
             <a:fld id="{B8663ADC-7E29-4153-BDB6-70B1CEFC7B31}" type="datetimeFigureOut">
               <a:rPr lang="en-IN" smtClean="0"/>
-              <a:t>04-09-2023</a:t>
+              <a:t>17-11-2025</a:t>
             </a:fld>
             <a:endParaRPr lang="en-IN"/>
           </a:p>
@@ -691,7 +691,7 @@
           <p:cNvPr id="5" name="Footer Placeholder 4">
             <a:extLst>
               <a:ext uri="{FF2B5EF4-FFF2-40B4-BE49-F238E27FC236}">
-                <a16:creationId xmlns:a16="http://schemas.microsoft.com/office/drawing/2014/main" xmlns="" id="{513EB533-8143-49F8-81D1-7A971AA3C3F2}"/>
+                <a16:creationId xmlns="" xmlns:a16="http://schemas.microsoft.com/office/drawing/2014/main" id="{513EB533-8143-49F8-81D1-7A971AA3C3F2}"/>
               </a:ext>
             </a:extLst>
           </p:cNvPr>
@@ -716,7 +716,7 @@
           <p:cNvPr id="6" name="Slide Number Placeholder 5">
             <a:extLst>
               <a:ext uri="{FF2B5EF4-FFF2-40B4-BE49-F238E27FC236}">
-                <a16:creationId xmlns:a16="http://schemas.microsoft.com/office/drawing/2014/main" xmlns="" id="{A0505364-EAD4-4581-8CAB-A681ACB18561}"/>
+                <a16:creationId xmlns="" xmlns:a16="http://schemas.microsoft.com/office/drawing/2014/main" id="{A0505364-EAD4-4581-8CAB-A681ACB18561}"/>
               </a:ext>
             </a:extLst>
           </p:cNvPr>
@@ -775,7 +775,7 @@
           <p:cNvPr id="2" name="Title 1">
             <a:extLst>
               <a:ext uri="{FF2B5EF4-FFF2-40B4-BE49-F238E27FC236}">
-                <a16:creationId xmlns:a16="http://schemas.microsoft.com/office/drawing/2014/main" xmlns="" id="{107F2014-2A01-4060-AD9A-48906D80216E}"/>
+                <a16:creationId xmlns="" xmlns:a16="http://schemas.microsoft.com/office/drawing/2014/main" id="{107F2014-2A01-4060-AD9A-48906D80216E}"/>
               </a:ext>
             </a:extLst>
           </p:cNvPr>
@@ -804,7 +804,7 @@
           <p:cNvPr id="3" name="Content Placeholder 2">
             <a:extLst>
               <a:ext uri="{FF2B5EF4-FFF2-40B4-BE49-F238E27FC236}">
-                <a16:creationId xmlns:a16="http://schemas.microsoft.com/office/drawing/2014/main" xmlns="" id="{BBB61DB2-59C0-499C-BA92-D10580A36EF1}"/>
+                <a16:creationId xmlns="" xmlns:a16="http://schemas.microsoft.com/office/drawing/2014/main" id="{BBB61DB2-59C0-499C-BA92-D10580A36EF1}"/>
               </a:ext>
             </a:extLst>
           </p:cNvPr>
@@ -862,7 +862,7 @@
           <p:cNvPr id="4" name="Date Placeholder 3">
             <a:extLst>
               <a:ext uri="{FF2B5EF4-FFF2-40B4-BE49-F238E27FC236}">
-                <a16:creationId xmlns:a16="http://schemas.microsoft.com/office/drawing/2014/main" xmlns="" id="{B1D1C93E-B609-4006-936A-A06D5962205A}"/>
+                <a16:creationId xmlns="" xmlns:a16="http://schemas.microsoft.com/office/drawing/2014/main" id="{B1D1C93E-B609-4006-936A-A06D5962205A}"/>
               </a:ext>
             </a:extLst>
           </p:cNvPr>
@@ -880,7 +880,7 @@
           <a:p>
             <a:fld id="{B8663ADC-7E29-4153-BDB6-70B1CEFC7B31}" type="datetimeFigureOut">
               <a:rPr lang="en-IN" smtClean="0"/>
-              <a:t>04-09-2023</a:t>
+              <a:t>17-11-2025</a:t>
             </a:fld>
             <a:endParaRPr lang="en-IN"/>
           </a:p>
@@ -891,7 +891,7 @@
           <p:cNvPr id="5" name="Footer Placeholder 4">
             <a:extLst>
               <a:ext uri="{FF2B5EF4-FFF2-40B4-BE49-F238E27FC236}">
-                <a16:creationId xmlns:a16="http://schemas.microsoft.com/office/drawing/2014/main" xmlns="" id="{9AB33411-7495-4EEC-9E43-6F8B257D92C2}"/>
+                <a16:creationId xmlns="" xmlns:a16="http://schemas.microsoft.com/office/drawing/2014/main" id="{9AB33411-7495-4EEC-9E43-6F8B257D92C2}"/>
               </a:ext>
             </a:extLst>
           </p:cNvPr>
@@ -916,7 +916,7 @@
           <p:cNvPr id="6" name="Slide Number Placeholder 5">
             <a:extLst>
               <a:ext uri="{FF2B5EF4-FFF2-40B4-BE49-F238E27FC236}">
-                <a16:creationId xmlns:a16="http://schemas.microsoft.com/office/drawing/2014/main" xmlns="" id="{998A7201-5FE7-4124-876C-49476E7C5F52}"/>
+                <a16:creationId xmlns="" xmlns:a16="http://schemas.microsoft.com/office/drawing/2014/main" id="{998A7201-5FE7-4124-876C-49476E7C5F52}"/>
               </a:ext>
             </a:extLst>
           </p:cNvPr>
@@ -975,7 +975,7 @@
           <p:cNvPr id="2" name="Title 1">
             <a:extLst>
               <a:ext uri="{FF2B5EF4-FFF2-40B4-BE49-F238E27FC236}">
-                <a16:creationId xmlns:a16="http://schemas.microsoft.com/office/drawing/2014/main" xmlns="" id="{0924F92D-5396-496B-80D1-402056B9A882}"/>
+                <a16:creationId xmlns="" xmlns:a16="http://schemas.microsoft.com/office/drawing/2014/main" id="{0924F92D-5396-496B-80D1-402056B9A882}"/>
               </a:ext>
             </a:extLst>
           </p:cNvPr>
@@ -1013,7 +1013,7 @@
           <p:cNvPr id="3" name="Text Placeholder 2">
             <a:extLst>
               <a:ext uri="{FF2B5EF4-FFF2-40B4-BE49-F238E27FC236}">
-                <a16:creationId xmlns:a16="http://schemas.microsoft.com/office/drawing/2014/main" xmlns="" id="{2B10DBE6-4E64-47EF-B090-572D4879E81D}"/>
+                <a16:creationId xmlns="" xmlns:a16="http://schemas.microsoft.com/office/drawing/2014/main" id="{2B10DBE6-4E64-47EF-B090-572D4879E81D}"/>
               </a:ext>
             </a:extLst>
           </p:cNvPr>
@@ -1138,7 +1138,7 @@
           <p:cNvPr id="4" name="Date Placeholder 3">
             <a:extLst>
               <a:ext uri="{FF2B5EF4-FFF2-40B4-BE49-F238E27FC236}">
-                <a16:creationId xmlns:a16="http://schemas.microsoft.com/office/drawing/2014/main" xmlns="" id="{63ADAB51-3277-4993-83C1-55E694C0F933}"/>
+                <a16:creationId xmlns="" xmlns:a16="http://schemas.microsoft.com/office/drawing/2014/main" id="{63ADAB51-3277-4993-83C1-55E694C0F933}"/>
               </a:ext>
             </a:extLst>
           </p:cNvPr>
@@ -1156,7 +1156,7 @@
           <a:p>
             <a:fld id="{B8663ADC-7E29-4153-BDB6-70B1CEFC7B31}" type="datetimeFigureOut">
               <a:rPr lang="en-IN" smtClean="0"/>
-              <a:t>04-09-2023</a:t>
+              <a:t>17-11-2025</a:t>
             </a:fld>
             <a:endParaRPr lang="en-IN"/>
           </a:p>
@@ -1167,7 +1167,7 @@
           <p:cNvPr id="5" name="Footer Placeholder 4">
             <a:extLst>
               <a:ext uri="{FF2B5EF4-FFF2-40B4-BE49-F238E27FC236}">
-                <a16:creationId xmlns:a16="http://schemas.microsoft.com/office/drawing/2014/main" xmlns="" id="{CC75B8A5-62B1-492A-A64F-9708619B6759}"/>
+                <a16:creationId xmlns="" xmlns:a16="http://schemas.microsoft.com/office/drawing/2014/main" id="{CC75B8A5-62B1-492A-A64F-9708619B6759}"/>
               </a:ext>
             </a:extLst>
           </p:cNvPr>
@@ -1192,7 +1192,7 @@
           <p:cNvPr id="6" name="Slide Number Placeholder 5">
             <a:extLst>
               <a:ext uri="{FF2B5EF4-FFF2-40B4-BE49-F238E27FC236}">
-                <a16:creationId xmlns:a16="http://schemas.microsoft.com/office/drawing/2014/main" xmlns="" id="{5B79707B-158D-48B5-83CA-88066E4221AF}"/>
+                <a16:creationId xmlns="" xmlns:a16="http://schemas.microsoft.com/office/drawing/2014/main" id="{5B79707B-158D-48B5-83CA-88066E4221AF}"/>
               </a:ext>
             </a:extLst>
           </p:cNvPr>
@@ -1251,7 +1251,7 @@
           <p:cNvPr id="2" name="Title 1">
             <a:extLst>
               <a:ext uri="{FF2B5EF4-FFF2-40B4-BE49-F238E27FC236}">
-                <a16:creationId xmlns:a16="http://schemas.microsoft.com/office/drawing/2014/main" xmlns="" id="{5953C639-95FA-4046-AA98-5AFFFDD797AD}"/>
+                <a16:creationId xmlns="" xmlns:a16="http://schemas.microsoft.com/office/drawing/2014/main" id="{5953C639-95FA-4046-AA98-5AFFFDD797AD}"/>
               </a:ext>
             </a:extLst>
           </p:cNvPr>
@@ -1280,7 +1280,7 @@
           <p:cNvPr id="3" name="Content Placeholder 2">
             <a:extLst>
               <a:ext uri="{FF2B5EF4-FFF2-40B4-BE49-F238E27FC236}">
-                <a16:creationId xmlns:a16="http://schemas.microsoft.com/office/drawing/2014/main" xmlns="" id="{068D3E60-59CC-48E2-9FD6-23728C9748F2}"/>
+                <a16:creationId xmlns="" xmlns:a16="http://schemas.microsoft.com/office/drawing/2014/main" id="{068D3E60-59CC-48E2-9FD6-23728C9748F2}"/>
               </a:ext>
             </a:extLst>
           </p:cNvPr>
@@ -1343,7 +1343,7 @@
           <p:cNvPr id="4" name="Content Placeholder 3">
             <a:extLst>
               <a:ext uri="{FF2B5EF4-FFF2-40B4-BE49-F238E27FC236}">
-                <a16:creationId xmlns:a16="http://schemas.microsoft.com/office/drawing/2014/main" xmlns="" id="{06529BF5-5DFF-4B58-8F8A-D20B39472635}"/>
+                <a16:creationId xmlns="" xmlns:a16="http://schemas.microsoft.com/office/drawing/2014/main" id="{06529BF5-5DFF-4B58-8F8A-D20B39472635}"/>
               </a:ext>
             </a:extLst>
           </p:cNvPr>
@@ -1406,7 +1406,7 @@
           <p:cNvPr id="5" name="Date Placeholder 4">
             <a:extLst>
               <a:ext uri="{FF2B5EF4-FFF2-40B4-BE49-F238E27FC236}">
-                <a16:creationId xmlns:a16="http://schemas.microsoft.com/office/drawing/2014/main" xmlns="" id="{EB9CA078-B340-4096-86EB-6B58F2D52ECA}"/>
+                <a16:creationId xmlns="" xmlns:a16="http://schemas.microsoft.com/office/drawing/2014/main" id="{EB9CA078-B340-4096-86EB-6B58F2D52ECA}"/>
               </a:ext>
             </a:extLst>
           </p:cNvPr>
@@ -1424,7 +1424,7 @@
           <a:p>
             <a:fld id="{B8663ADC-7E29-4153-BDB6-70B1CEFC7B31}" type="datetimeFigureOut">
               <a:rPr lang="en-IN" smtClean="0"/>
-              <a:t>04-09-2023</a:t>
+              <a:t>17-11-2025</a:t>
             </a:fld>
             <a:endParaRPr lang="en-IN"/>
           </a:p>
@@ -1435,7 +1435,7 @@
           <p:cNvPr id="6" name="Footer Placeholder 5">
             <a:extLst>
               <a:ext uri="{FF2B5EF4-FFF2-40B4-BE49-F238E27FC236}">
-                <a16:creationId xmlns:a16="http://schemas.microsoft.com/office/drawing/2014/main" xmlns="" id="{595F4B29-E1E3-4516-9549-2F197059D8C4}"/>
+                <a16:creationId xmlns="" xmlns:a16="http://schemas.microsoft.com/office/drawing/2014/main" id="{595F4B29-E1E3-4516-9549-2F197059D8C4}"/>
               </a:ext>
             </a:extLst>
           </p:cNvPr>
@@ -1460,7 +1460,7 @@
           <p:cNvPr id="7" name="Slide Number Placeholder 6">
             <a:extLst>
               <a:ext uri="{FF2B5EF4-FFF2-40B4-BE49-F238E27FC236}">
-                <a16:creationId xmlns:a16="http://schemas.microsoft.com/office/drawing/2014/main" xmlns="" id="{CFEA1260-F9BC-4EC8-A4E8-2E1D0F5C2C32}"/>
+                <a16:creationId xmlns="" xmlns:a16="http://schemas.microsoft.com/office/drawing/2014/main" id="{CFEA1260-F9BC-4EC8-A4E8-2E1D0F5C2C32}"/>
               </a:ext>
             </a:extLst>
           </p:cNvPr>
@@ -1519,7 +1519,7 @@
           <p:cNvPr id="2" name="Title 1">
             <a:extLst>
               <a:ext uri="{FF2B5EF4-FFF2-40B4-BE49-F238E27FC236}">
-                <a16:creationId xmlns:a16="http://schemas.microsoft.com/office/drawing/2014/main" xmlns="" id="{91324A98-2D22-4503-BF81-EEE8604B0248}"/>
+                <a16:creationId xmlns="" xmlns:a16="http://schemas.microsoft.com/office/drawing/2014/main" id="{91324A98-2D22-4503-BF81-EEE8604B0248}"/>
               </a:ext>
             </a:extLst>
           </p:cNvPr>
@@ -1553,7 +1553,7 @@
           <p:cNvPr id="3" name="Text Placeholder 2">
             <a:extLst>
               <a:ext uri="{FF2B5EF4-FFF2-40B4-BE49-F238E27FC236}">
-                <a16:creationId xmlns:a16="http://schemas.microsoft.com/office/drawing/2014/main" xmlns="" id="{FCD2AE5F-26DF-47D2-8EBD-F3DAC852AEB8}"/>
+                <a16:creationId xmlns="" xmlns:a16="http://schemas.microsoft.com/office/drawing/2014/main" id="{FCD2AE5F-26DF-47D2-8EBD-F3DAC852AEB8}"/>
               </a:ext>
             </a:extLst>
           </p:cNvPr>
@@ -1624,7 +1624,7 @@
           <p:cNvPr id="4" name="Content Placeholder 3">
             <a:extLst>
               <a:ext uri="{FF2B5EF4-FFF2-40B4-BE49-F238E27FC236}">
-                <a16:creationId xmlns:a16="http://schemas.microsoft.com/office/drawing/2014/main" xmlns="" id="{7552DBFF-1113-48D9-BB07-6AB4D70879DE}"/>
+                <a16:creationId xmlns="" xmlns:a16="http://schemas.microsoft.com/office/drawing/2014/main" id="{7552DBFF-1113-48D9-BB07-6AB4D70879DE}"/>
               </a:ext>
             </a:extLst>
           </p:cNvPr>
@@ -1687,7 +1687,7 @@
           <p:cNvPr id="5" name="Text Placeholder 4">
             <a:extLst>
               <a:ext uri="{FF2B5EF4-FFF2-40B4-BE49-F238E27FC236}">
-                <a16:creationId xmlns:a16="http://schemas.microsoft.com/office/drawing/2014/main" xmlns="" id="{BF90233B-3F11-4B04-A84B-1669CB6F63D5}"/>
+                <a16:creationId xmlns="" xmlns:a16="http://schemas.microsoft.com/office/drawing/2014/main" id="{BF90233B-3F11-4B04-A84B-1669CB6F63D5}"/>
               </a:ext>
             </a:extLst>
           </p:cNvPr>
@@ -1758,7 +1758,7 @@
           <p:cNvPr id="6" name="Content Placeholder 5">
             <a:extLst>
               <a:ext uri="{FF2B5EF4-FFF2-40B4-BE49-F238E27FC236}">
-                <a16:creationId xmlns:a16="http://schemas.microsoft.com/office/drawing/2014/main" xmlns="" id="{89F8DC42-0545-4779-943A-091304974E37}"/>
+                <a16:creationId xmlns="" xmlns:a16="http://schemas.microsoft.com/office/drawing/2014/main" id="{89F8DC42-0545-4779-943A-091304974E37}"/>
               </a:ext>
             </a:extLst>
           </p:cNvPr>
@@ -1821,7 +1821,7 @@
           <p:cNvPr id="7" name="Date Placeholder 6">
             <a:extLst>
               <a:ext uri="{FF2B5EF4-FFF2-40B4-BE49-F238E27FC236}">
-                <a16:creationId xmlns:a16="http://schemas.microsoft.com/office/drawing/2014/main" xmlns="" id="{75926BE9-D74A-4BCE-AF86-AD2A1AAB6D68}"/>
+                <a16:creationId xmlns="" xmlns:a16="http://schemas.microsoft.com/office/drawing/2014/main" id="{75926BE9-D74A-4BCE-AF86-AD2A1AAB6D68}"/>
               </a:ext>
             </a:extLst>
           </p:cNvPr>
@@ -1839,7 +1839,7 @@
           <a:p>
             <a:fld id="{B8663ADC-7E29-4153-BDB6-70B1CEFC7B31}" type="datetimeFigureOut">
               <a:rPr lang="en-IN" smtClean="0"/>
-              <a:t>04-09-2023</a:t>
+              <a:t>17-11-2025</a:t>
             </a:fld>
             <a:endParaRPr lang="en-IN"/>
           </a:p>
@@ -1850,7 +1850,7 @@
           <p:cNvPr id="8" name="Footer Placeholder 7">
             <a:extLst>
               <a:ext uri="{FF2B5EF4-FFF2-40B4-BE49-F238E27FC236}">
-                <a16:creationId xmlns:a16="http://schemas.microsoft.com/office/drawing/2014/main" xmlns="" id="{CBFDC17A-5097-423B-94CB-088B7CABCE93}"/>
+                <a16:creationId xmlns="" xmlns:a16="http://schemas.microsoft.com/office/drawing/2014/main" id="{CBFDC17A-5097-423B-94CB-088B7CABCE93}"/>
               </a:ext>
             </a:extLst>
           </p:cNvPr>
@@ -1875,7 +1875,7 @@
           <p:cNvPr id="9" name="Slide Number Placeholder 8">
             <a:extLst>
               <a:ext uri="{FF2B5EF4-FFF2-40B4-BE49-F238E27FC236}">
-                <a16:creationId xmlns:a16="http://schemas.microsoft.com/office/drawing/2014/main" xmlns="" id="{DD0276DB-DE02-4146-95B7-18B52187E131}"/>
+                <a16:creationId xmlns="" xmlns:a16="http://schemas.microsoft.com/office/drawing/2014/main" id="{DD0276DB-DE02-4146-95B7-18B52187E131}"/>
               </a:ext>
             </a:extLst>
           </p:cNvPr>
@@ -1934,7 +1934,7 @@
           <p:cNvPr id="2" name="Title 1">
             <a:extLst>
               <a:ext uri="{FF2B5EF4-FFF2-40B4-BE49-F238E27FC236}">
-                <a16:creationId xmlns:a16="http://schemas.microsoft.com/office/drawing/2014/main" xmlns="" id="{E76827FE-2A27-4C5B-89A6-09701436EC3B}"/>
+                <a16:creationId xmlns="" xmlns:a16="http://schemas.microsoft.com/office/drawing/2014/main" id="{E76827FE-2A27-4C5B-89A6-09701436EC3B}"/>
               </a:ext>
             </a:extLst>
           </p:cNvPr>
@@ -1963,7 +1963,7 @@
           <p:cNvPr id="3" name="Date Placeholder 2">
             <a:extLst>
               <a:ext uri="{FF2B5EF4-FFF2-40B4-BE49-F238E27FC236}">
-                <a16:creationId xmlns:a16="http://schemas.microsoft.com/office/drawing/2014/main" xmlns="" id="{882825B8-A0AA-40F0-B27E-1416A850C2D9}"/>
+                <a16:creationId xmlns="" xmlns:a16="http://schemas.microsoft.com/office/drawing/2014/main" id="{882825B8-A0AA-40F0-B27E-1416A850C2D9}"/>
               </a:ext>
             </a:extLst>
           </p:cNvPr>
@@ -1981,7 +1981,7 @@
           <a:p>
             <a:fld id="{B8663ADC-7E29-4153-BDB6-70B1CEFC7B31}" type="datetimeFigureOut">
               <a:rPr lang="en-IN" smtClean="0"/>
-              <a:t>04-09-2023</a:t>
+              <a:t>17-11-2025</a:t>
             </a:fld>
             <a:endParaRPr lang="en-IN"/>
           </a:p>
@@ -1992,7 +1992,7 @@
           <p:cNvPr id="4" name="Footer Placeholder 3">
             <a:extLst>
               <a:ext uri="{FF2B5EF4-FFF2-40B4-BE49-F238E27FC236}">
-                <a16:creationId xmlns:a16="http://schemas.microsoft.com/office/drawing/2014/main" xmlns="" id="{4EE1AFA7-33C4-4E5C-BB79-6D6263C05FEC}"/>
+                <a16:creationId xmlns="" xmlns:a16="http://schemas.microsoft.com/office/drawing/2014/main" id="{4EE1AFA7-33C4-4E5C-BB79-6D6263C05FEC}"/>
               </a:ext>
             </a:extLst>
           </p:cNvPr>
@@ -2017,7 +2017,7 @@
           <p:cNvPr id="5" name="Slide Number Placeholder 4">
             <a:extLst>
               <a:ext uri="{FF2B5EF4-FFF2-40B4-BE49-F238E27FC236}">
-                <a16:creationId xmlns:a16="http://schemas.microsoft.com/office/drawing/2014/main" xmlns="" id="{EE2D6023-5C1F-4E3D-BBAA-56B8B3B5D635}"/>
+                <a16:creationId xmlns="" xmlns:a16="http://schemas.microsoft.com/office/drawing/2014/main" id="{EE2D6023-5C1F-4E3D-BBAA-56B8B3B5D635}"/>
               </a:ext>
             </a:extLst>
           </p:cNvPr>
@@ -2076,7 +2076,7 @@
           <p:cNvPr id="2" name="Date Placeholder 1">
             <a:extLst>
               <a:ext uri="{FF2B5EF4-FFF2-40B4-BE49-F238E27FC236}">
-                <a16:creationId xmlns:a16="http://schemas.microsoft.com/office/drawing/2014/main" xmlns="" id="{9539800B-4411-4379-BD06-03F1D69AD171}"/>
+                <a16:creationId xmlns="" xmlns:a16="http://schemas.microsoft.com/office/drawing/2014/main" id="{9539800B-4411-4379-BD06-03F1D69AD171}"/>
               </a:ext>
             </a:extLst>
           </p:cNvPr>
@@ -2094,7 +2094,7 @@
           <a:p>
             <a:fld id="{B8663ADC-7E29-4153-BDB6-70B1CEFC7B31}" type="datetimeFigureOut">
               <a:rPr lang="en-IN" smtClean="0"/>
-              <a:t>04-09-2023</a:t>
+              <a:t>17-11-2025</a:t>
             </a:fld>
             <a:endParaRPr lang="en-IN"/>
           </a:p>
@@ -2105,7 +2105,7 @@
           <p:cNvPr id="3" name="Footer Placeholder 2">
             <a:extLst>
               <a:ext uri="{FF2B5EF4-FFF2-40B4-BE49-F238E27FC236}">
-                <a16:creationId xmlns:a16="http://schemas.microsoft.com/office/drawing/2014/main" xmlns="" id="{9DF47E39-CC37-46F6-A53A-413038922F94}"/>
+                <a16:creationId xmlns="" xmlns:a16="http://schemas.microsoft.com/office/drawing/2014/main" id="{9DF47E39-CC37-46F6-A53A-413038922F94}"/>
               </a:ext>
             </a:extLst>
           </p:cNvPr>
@@ -2130,7 +2130,7 @@
           <p:cNvPr id="4" name="Slide Number Placeholder 3">
             <a:extLst>
               <a:ext uri="{FF2B5EF4-FFF2-40B4-BE49-F238E27FC236}">
-                <a16:creationId xmlns:a16="http://schemas.microsoft.com/office/drawing/2014/main" xmlns="" id="{42D5231C-8681-49E8-BC21-3D324979BA09}"/>
+                <a16:creationId xmlns="" xmlns:a16="http://schemas.microsoft.com/office/drawing/2014/main" id="{42D5231C-8681-49E8-BC21-3D324979BA09}"/>
               </a:ext>
             </a:extLst>
           </p:cNvPr>
@@ -2189,7 +2189,7 @@
           <p:cNvPr id="2" name="Title 1">
             <a:extLst>
               <a:ext uri="{FF2B5EF4-FFF2-40B4-BE49-F238E27FC236}">
-                <a16:creationId xmlns:a16="http://schemas.microsoft.com/office/drawing/2014/main" xmlns="" id="{18E757C2-613A-4EAF-9C17-E752A5EBA65C}"/>
+                <a16:creationId xmlns="" xmlns:a16="http://schemas.microsoft.com/office/drawing/2014/main" id="{18E757C2-613A-4EAF-9C17-E752A5EBA65C}"/>
               </a:ext>
             </a:extLst>
           </p:cNvPr>
@@ -2227,7 +2227,7 @@
           <p:cNvPr id="3" name="Content Placeholder 2">
             <a:extLst>
               <a:ext uri="{FF2B5EF4-FFF2-40B4-BE49-F238E27FC236}">
-                <a16:creationId xmlns:a16="http://schemas.microsoft.com/office/drawing/2014/main" xmlns="" id="{9B503D4D-1581-483D-A48A-2ECDB8991362}"/>
+                <a16:creationId xmlns="" xmlns:a16="http://schemas.microsoft.com/office/drawing/2014/main" id="{9B503D4D-1581-483D-A48A-2ECDB8991362}"/>
               </a:ext>
             </a:extLst>
           </p:cNvPr>
@@ -2318,7 +2318,7 @@
           <p:cNvPr id="4" name="Text Placeholder 3">
             <a:extLst>
               <a:ext uri="{FF2B5EF4-FFF2-40B4-BE49-F238E27FC236}">
-                <a16:creationId xmlns:a16="http://schemas.microsoft.com/office/drawing/2014/main" xmlns="" id="{002DFC49-83E1-452A-A60B-D1BB549EF19B}"/>
+                <a16:creationId xmlns="" xmlns:a16="http://schemas.microsoft.com/office/drawing/2014/main" id="{002DFC49-83E1-452A-A60B-D1BB549EF19B}"/>
               </a:ext>
             </a:extLst>
           </p:cNvPr>
@@ -2389,7 +2389,7 @@
           <p:cNvPr id="5" name="Date Placeholder 4">
             <a:extLst>
               <a:ext uri="{FF2B5EF4-FFF2-40B4-BE49-F238E27FC236}">
-                <a16:creationId xmlns:a16="http://schemas.microsoft.com/office/drawing/2014/main" xmlns="" id="{B307A907-AD49-432A-B443-2038557887F4}"/>
+                <a16:creationId xmlns="" xmlns:a16="http://schemas.microsoft.com/office/drawing/2014/main" id="{B307A907-AD49-432A-B443-2038557887F4}"/>
               </a:ext>
             </a:extLst>
           </p:cNvPr>
@@ -2407,7 +2407,7 @@
           <a:p>
             <a:fld id="{B8663ADC-7E29-4153-BDB6-70B1CEFC7B31}" type="datetimeFigureOut">
               <a:rPr lang="en-IN" smtClean="0"/>
-              <a:t>04-09-2023</a:t>
+              <a:t>17-11-2025</a:t>
             </a:fld>
             <a:endParaRPr lang="en-IN"/>
           </a:p>
@@ -2418,7 +2418,7 @@
           <p:cNvPr id="6" name="Footer Placeholder 5">
             <a:extLst>
               <a:ext uri="{FF2B5EF4-FFF2-40B4-BE49-F238E27FC236}">
-                <a16:creationId xmlns:a16="http://schemas.microsoft.com/office/drawing/2014/main" xmlns="" id="{FC82B4A4-D76E-46ED-B390-CBDCFFB11665}"/>
+                <a16:creationId xmlns="" xmlns:a16="http://schemas.microsoft.com/office/drawing/2014/main" id="{FC82B4A4-D76E-46ED-B390-CBDCFFB11665}"/>
               </a:ext>
             </a:extLst>
           </p:cNvPr>
@@ -2443,7 +2443,7 @@
           <p:cNvPr id="7" name="Slide Number Placeholder 6">
             <a:extLst>
               <a:ext uri="{FF2B5EF4-FFF2-40B4-BE49-F238E27FC236}">
-                <a16:creationId xmlns:a16="http://schemas.microsoft.com/office/drawing/2014/main" xmlns="" id="{42DCB435-A0D4-4156-BAAD-111C47E80960}"/>
+                <a16:creationId xmlns="" xmlns:a16="http://schemas.microsoft.com/office/drawing/2014/main" id="{42DCB435-A0D4-4156-BAAD-111C47E80960}"/>
               </a:ext>
             </a:extLst>
           </p:cNvPr>
@@ -2502,7 +2502,7 @@
           <p:cNvPr id="2" name="Title 1">
             <a:extLst>
               <a:ext uri="{FF2B5EF4-FFF2-40B4-BE49-F238E27FC236}">
-                <a16:creationId xmlns:a16="http://schemas.microsoft.com/office/drawing/2014/main" xmlns="" id="{44336B39-56C0-43ED-AB01-1F598E4A58A0}"/>
+                <a16:creationId xmlns="" xmlns:a16="http://schemas.microsoft.com/office/drawing/2014/main" id="{44336B39-56C0-43ED-AB01-1F598E4A58A0}"/>
               </a:ext>
             </a:extLst>
           </p:cNvPr>
@@ -2540,7 +2540,7 @@
           <p:cNvPr id="3" name="Picture Placeholder 2">
             <a:extLst>
               <a:ext uri="{FF2B5EF4-FFF2-40B4-BE49-F238E27FC236}">
-                <a16:creationId xmlns:a16="http://schemas.microsoft.com/office/drawing/2014/main" xmlns="" id="{82252D61-502C-4FB7-A850-CC70808AD68F}"/>
+                <a16:creationId xmlns="" xmlns:a16="http://schemas.microsoft.com/office/drawing/2014/main" id="{82252D61-502C-4FB7-A850-CC70808AD68F}"/>
               </a:ext>
             </a:extLst>
           </p:cNvPr>
@@ -2607,7 +2607,7 @@
           <p:cNvPr id="4" name="Text Placeholder 3">
             <a:extLst>
               <a:ext uri="{FF2B5EF4-FFF2-40B4-BE49-F238E27FC236}">
-                <a16:creationId xmlns:a16="http://schemas.microsoft.com/office/drawing/2014/main" xmlns="" id="{A6E616A0-8680-49E0-96B4-77A67C93129A}"/>
+                <a16:creationId xmlns="" xmlns:a16="http://schemas.microsoft.com/office/drawing/2014/main" id="{A6E616A0-8680-49E0-96B4-77A67C93129A}"/>
               </a:ext>
             </a:extLst>
           </p:cNvPr>
@@ -2678,7 +2678,7 @@
           <p:cNvPr id="5" name="Date Placeholder 4">
             <a:extLst>
               <a:ext uri="{FF2B5EF4-FFF2-40B4-BE49-F238E27FC236}">
-                <a16:creationId xmlns:a16="http://schemas.microsoft.com/office/drawing/2014/main" xmlns="" id="{C029AE0A-4C31-4295-950C-815CD0A6AA15}"/>
+                <a16:creationId xmlns="" xmlns:a16="http://schemas.microsoft.com/office/drawing/2014/main" id="{C029AE0A-4C31-4295-950C-815CD0A6AA15}"/>
               </a:ext>
             </a:extLst>
           </p:cNvPr>
@@ -2696,7 +2696,7 @@
           <a:p>
             <a:fld id="{B8663ADC-7E29-4153-BDB6-70B1CEFC7B31}" type="datetimeFigureOut">
               <a:rPr lang="en-IN" smtClean="0"/>
-              <a:t>04-09-2023</a:t>
+              <a:t>17-11-2025</a:t>
             </a:fld>
             <a:endParaRPr lang="en-IN"/>
           </a:p>
@@ -2707,7 +2707,7 @@
           <p:cNvPr id="6" name="Footer Placeholder 5">
             <a:extLst>
               <a:ext uri="{FF2B5EF4-FFF2-40B4-BE49-F238E27FC236}">
-                <a16:creationId xmlns:a16="http://schemas.microsoft.com/office/drawing/2014/main" xmlns="" id="{3790DA52-9377-45CC-8E6D-753BD52AD900}"/>
+                <a16:creationId xmlns="" xmlns:a16="http://schemas.microsoft.com/office/drawing/2014/main" id="{3790DA52-9377-45CC-8E6D-753BD52AD900}"/>
               </a:ext>
             </a:extLst>
           </p:cNvPr>
@@ -2732,7 +2732,7 @@
           <p:cNvPr id="7" name="Slide Number Placeholder 6">
             <a:extLst>
               <a:ext uri="{FF2B5EF4-FFF2-40B4-BE49-F238E27FC236}">
-                <a16:creationId xmlns:a16="http://schemas.microsoft.com/office/drawing/2014/main" xmlns="" id="{C52E01B4-52AA-4841-B7A6-43B897FADBAC}"/>
+                <a16:creationId xmlns="" xmlns:a16="http://schemas.microsoft.com/office/drawing/2014/main" id="{C52E01B4-52AA-4841-B7A6-43B897FADBAC}"/>
               </a:ext>
             </a:extLst>
           </p:cNvPr>
@@ -2796,7 +2796,7 @@
           <p:cNvPr id="2" name="Title Placeholder 1">
             <a:extLst>
               <a:ext uri="{FF2B5EF4-FFF2-40B4-BE49-F238E27FC236}">
-                <a16:creationId xmlns:a16="http://schemas.microsoft.com/office/drawing/2014/main" xmlns="" id="{76DE419A-2610-4F89-9DEC-1EDAD1AE2380}"/>
+                <a16:creationId xmlns="" xmlns:a16="http://schemas.microsoft.com/office/drawing/2014/main" id="{76DE419A-2610-4F89-9DEC-1EDAD1AE2380}"/>
               </a:ext>
             </a:extLst>
           </p:cNvPr>
@@ -2835,7 +2835,7 @@
           <p:cNvPr id="3" name="Text Placeholder 2">
             <a:extLst>
               <a:ext uri="{FF2B5EF4-FFF2-40B4-BE49-F238E27FC236}">
-                <a16:creationId xmlns:a16="http://schemas.microsoft.com/office/drawing/2014/main" xmlns="" id="{AB0EBBC5-272E-4D99-910B-ED3E8F18DF2E}"/>
+                <a16:creationId xmlns="" xmlns:a16="http://schemas.microsoft.com/office/drawing/2014/main" id="{AB0EBBC5-272E-4D99-910B-ED3E8F18DF2E}"/>
               </a:ext>
             </a:extLst>
           </p:cNvPr>
@@ -2903,7 +2903,7 @@
           <p:cNvPr id="4" name="Date Placeholder 3">
             <a:extLst>
               <a:ext uri="{FF2B5EF4-FFF2-40B4-BE49-F238E27FC236}">
-                <a16:creationId xmlns:a16="http://schemas.microsoft.com/office/drawing/2014/main" xmlns="" id="{077B7163-E19D-4640-9E95-A92819F1570D}"/>
+                <a16:creationId xmlns="" xmlns:a16="http://schemas.microsoft.com/office/drawing/2014/main" id="{077B7163-E19D-4640-9E95-A92819F1570D}"/>
               </a:ext>
             </a:extLst>
           </p:cNvPr>
@@ -2939,7 +2939,7 @@
           <a:p>
             <a:fld id="{B8663ADC-7E29-4153-BDB6-70B1CEFC7B31}" type="datetimeFigureOut">
               <a:rPr lang="en-IN" smtClean="0"/>
-              <a:t>04-09-2023</a:t>
+              <a:t>17-11-2025</a:t>
             </a:fld>
             <a:endParaRPr lang="en-IN"/>
           </a:p>
@@ -2950,7 +2950,7 @@
           <p:cNvPr id="5" name="Footer Placeholder 4">
             <a:extLst>
               <a:ext uri="{FF2B5EF4-FFF2-40B4-BE49-F238E27FC236}">
-                <a16:creationId xmlns:a16="http://schemas.microsoft.com/office/drawing/2014/main" xmlns="" id="{67FE0063-98E0-4F41-98C2-F187D8ECF4CF}"/>
+                <a16:creationId xmlns="" xmlns:a16="http://schemas.microsoft.com/office/drawing/2014/main" id="{67FE0063-98E0-4F41-98C2-F187D8ECF4CF}"/>
               </a:ext>
             </a:extLst>
           </p:cNvPr>
@@ -2993,7 +2993,7 @@
           <p:cNvPr id="6" name="Slide Number Placeholder 5">
             <a:extLst>
               <a:ext uri="{FF2B5EF4-FFF2-40B4-BE49-F238E27FC236}">
-                <a16:creationId xmlns:a16="http://schemas.microsoft.com/office/drawing/2014/main" xmlns="" id="{EEBDAACD-1388-4B9A-BEB7-1326CC015F61}"/>
+                <a16:creationId xmlns="" xmlns:a16="http://schemas.microsoft.com/office/drawing/2014/main" id="{EEBDAACD-1388-4B9A-BEB7-1326CC015F61}"/>
               </a:ext>
             </a:extLst>
           </p:cNvPr>
@@ -3361,7 +3361,7 @@
           <p:cNvPr id="2" name="Title 1">
             <a:extLst>
               <a:ext uri="{FF2B5EF4-FFF2-40B4-BE49-F238E27FC236}">
-                <a16:creationId xmlns:a16="http://schemas.microsoft.com/office/drawing/2014/main" xmlns="" id="{296F054F-811C-41A0-9993-073953589A0B}"/>
+                <a16:creationId xmlns="" xmlns:a16="http://schemas.microsoft.com/office/drawing/2014/main" id="{296F054F-811C-41A0-9993-073953589A0B}"/>
               </a:ext>
             </a:extLst>
           </p:cNvPr>
@@ -3389,7 +3389,7 @@
           <p:cNvPr id="3" name="Subtitle 2">
             <a:extLst>
               <a:ext uri="{FF2B5EF4-FFF2-40B4-BE49-F238E27FC236}">
-                <a16:creationId xmlns:a16="http://schemas.microsoft.com/office/drawing/2014/main" xmlns="" id="{461D7CD6-AB3B-4403-B41F-7DD705B3DA8B}"/>
+                <a16:creationId xmlns="" xmlns:a16="http://schemas.microsoft.com/office/drawing/2014/main" id="{461D7CD6-AB3B-4403-B41F-7DD705B3DA8B}"/>
               </a:ext>
             </a:extLst>
           </p:cNvPr>
@@ -3451,7 +3451,7 @@
           <p:cNvPr id="2" name="Title 1">
             <a:extLst>
               <a:ext uri="{FF2B5EF4-FFF2-40B4-BE49-F238E27FC236}">
-                <a16:creationId xmlns:a16="http://schemas.microsoft.com/office/drawing/2014/main" xmlns="" id="{6EA23D26-98BC-4BD9-B73D-AA8A045BCB30}"/>
+                <a16:creationId xmlns="" xmlns:a16="http://schemas.microsoft.com/office/drawing/2014/main" id="{6EA23D26-98BC-4BD9-B73D-AA8A045BCB30}"/>
               </a:ext>
             </a:extLst>
           </p:cNvPr>
@@ -3486,7 +3486,7 @@
           <p:cNvPr id="6" name="TextBox 5">
             <a:extLst>
               <a:ext uri="{FF2B5EF4-FFF2-40B4-BE49-F238E27FC236}">
-                <a16:creationId xmlns:a16="http://schemas.microsoft.com/office/drawing/2014/main" xmlns="" id="{625C355E-AB42-40C3-86EA-76E3999EEF5B}"/>
+                <a16:creationId xmlns="" xmlns:a16="http://schemas.microsoft.com/office/drawing/2014/main" id="{625C355E-AB42-40C3-86EA-76E3999EEF5B}"/>
               </a:ext>
             </a:extLst>
           </p:cNvPr>
@@ -3858,7 +3858,7 @@
           <p:cNvPr id="2" name="Title 1">
             <a:extLst>
               <a:ext uri="{FF2B5EF4-FFF2-40B4-BE49-F238E27FC236}">
-                <a16:creationId xmlns:a16="http://schemas.microsoft.com/office/drawing/2014/main" xmlns="" id="{873E8AD7-F0DC-4B92-96C8-AD4DB675A08D}"/>
+                <a16:creationId xmlns="" xmlns:a16="http://schemas.microsoft.com/office/drawing/2014/main" id="{873E8AD7-F0DC-4B92-96C8-AD4DB675A08D}"/>
               </a:ext>
             </a:extLst>
           </p:cNvPr>
@@ -3886,7 +3886,7 @@
           <p:cNvPr id="3" name="Content Placeholder 2">
             <a:extLst>
               <a:ext uri="{FF2B5EF4-FFF2-40B4-BE49-F238E27FC236}">
-                <a16:creationId xmlns:a16="http://schemas.microsoft.com/office/drawing/2014/main" xmlns="" id="{992A7DBD-1149-4615-A855-A950C0915ECE}"/>
+                <a16:creationId xmlns="" xmlns:a16="http://schemas.microsoft.com/office/drawing/2014/main" id="{992A7DBD-1149-4615-A855-A950C0915ECE}"/>
               </a:ext>
             </a:extLst>
           </p:cNvPr>
@@ -3977,7 +3977,7 @@
           <p:cNvPr id="2" name="Title 1">
             <a:extLst>
               <a:ext uri="{FF2B5EF4-FFF2-40B4-BE49-F238E27FC236}">
-                <a16:creationId xmlns:a16="http://schemas.microsoft.com/office/drawing/2014/main" xmlns="" id="{1B8CAE36-8B29-4170-A814-8E26A86C9A45}"/>
+                <a16:creationId xmlns="" xmlns:a16="http://schemas.microsoft.com/office/drawing/2014/main" id="{1B8CAE36-8B29-4170-A814-8E26A86C9A45}"/>
               </a:ext>
             </a:extLst>
           </p:cNvPr>
@@ -4010,7 +4010,7 @@
           <p:cNvPr id="3" name="Content Placeholder 2">
             <a:extLst>
               <a:ext uri="{FF2B5EF4-FFF2-40B4-BE49-F238E27FC236}">
-                <a16:creationId xmlns:a16="http://schemas.microsoft.com/office/drawing/2014/main" xmlns="" id="{F095D5B1-16DB-4840-8E9F-A50B7622D4EE}"/>
+                <a16:creationId xmlns="" xmlns:a16="http://schemas.microsoft.com/office/drawing/2014/main" id="{F095D5B1-16DB-4840-8E9F-A50B7622D4EE}"/>
               </a:ext>
             </a:extLst>
           </p:cNvPr>
@@ -4165,7 +4165,7 @@
           <p:cNvPr id="3" name="Content Placeholder 2">
             <a:extLst>
               <a:ext uri="{FF2B5EF4-FFF2-40B4-BE49-F238E27FC236}">
-                <a16:creationId xmlns:a16="http://schemas.microsoft.com/office/drawing/2014/main" xmlns="" id="{C00655C8-F009-49F3-B598-A199A02EAFBD}"/>
+                <a16:creationId xmlns="" xmlns:a16="http://schemas.microsoft.com/office/drawing/2014/main" id="{C00655C8-F009-49F3-B598-A199A02EAFBD}"/>
               </a:ext>
             </a:extLst>
           </p:cNvPr>
@@ -4432,7 +4432,7 @@
           <p:cNvPr id="2" name="Title 1">
             <a:extLst>
               <a:ext uri="{FF2B5EF4-FFF2-40B4-BE49-F238E27FC236}">
-                <a16:creationId xmlns:a16="http://schemas.microsoft.com/office/drawing/2014/main" xmlns="" id="{8AFEC93B-0B64-4E04-9723-6A88B53E0129}"/>
+                <a16:creationId xmlns="" xmlns:a16="http://schemas.microsoft.com/office/drawing/2014/main" id="{8AFEC93B-0B64-4E04-9723-6A88B53E0129}"/>
               </a:ext>
             </a:extLst>
           </p:cNvPr>
@@ -4460,7 +4460,7 @@
           <p:cNvPr id="5" name="Picture 4">
             <a:extLst>
               <a:ext uri="{FF2B5EF4-FFF2-40B4-BE49-F238E27FC236}">
-                <a16:creationId xmlns:a16="http://schemas.microsoft.com/office/drawing/2014/main" xmlns="" id="{4864930C-8414-4BF3-91C0-41ED4941EF70}"/>
+                <a16:creationId xmlns="" xmlns:a16="http://schemas.microsoft.com/office/drawing/2014/main" id="{4864930C-8414-4BF3-91C0-41ED4941EF70}"/>
               </a:ext>
             </a:extLst>
           </p:cNvPr>
@@ -4520,7 +4520,7 @@
           <p:cNvPr id="2" name="Title 1">
             <a:extLst>
               <a:ext uri="{FF2B5EF4-FFF2-40B4-BE49-F238E27FC236}">
-                <a16:creationId xmlns:a16="http://schemas.microsoft.com/office/drawing/2014/main" xmlns="" id="{C734B1AF-9697-4D70-9600-BA2F1D4F0657}"/>
+                <a16:creationId xmlns="" xmlns:a16="http://schemas.microsoft.com/office/drawing/2014/main" id="{C734B1AF-9697-4D70-9600-BA2F1D4F0657}"/>
               </a:ext>
             </a:extLst>
           </p:cNvPr>
@@ -4548,7 +4548,7 @@
           <p:cNvPr id="6" name="TextBox 5">
             <a:extLst>
               <a:ext uri="{FF2B5EF4-FFF2-40B4-BE49-F238E27FC236}">
-                <a16:creationId xmlns:a16="http://schemas.microsoft.com/office/drawing/2014/main" xmlns="" id="{ABFD70D9-8070-40A6-AE12-9F72CB193401}"/>
+                <a16:creationId xmlns="" xmlns:a16="http://schemas.microsoft.com/office/drawing/2014/main" id="{ABFD70D9-8070-40A6-AE12-9F72CB193401}"/>
               </a:ext>
             </a:extLst>
           </p:cNvPr>
@@ -4824,7 +4824,7 @@
           <p:cNvPr id="2" name="Title 1">
             <a:extLst>
               <a:ext uri="{FF2B5EF4-FFF2-40B4-BE49-F238E27FC236}">
-                <a16:creationId xmlns:a16="http://schemas.microsoft.com/office/drawing/2014/main" xmlns="" id="{E6AE50EC-572D-47B5-A644-F1DE039D4E4D}"/>
+                <a16:creationId xmlns="" xmlns:a16="http://schemas.microsoft.com/office/drawing/2014/main" id="{E6AE50EC-572D-47B5-A644-F1DE039D4E4D}"/>
               </a:ext>
             </a:extLst>
           </p:cNvPr>
@@ -4857,7 +4857,7 @@
           <p:cNvPr id="3" name="Content Placeholder 2">
             <a:extLst>
               <a:ext uri="{FF2B5EF4-FFF2-40B4-BE49-F238E27FC236}">
-                <a16:creationId xmlns:a16="http://schemas.microsoft.com/office/drawing/2014/main" xmlns="" id="{57282813-343E-48F6-A1B7-68811E5C0F24}"/>
+                <a16:creationId xmlns="" xmlns:a16="http://schemas.microsoft.com/office/drawing/2014/main" id="{57282813-343E-48F6-A1B7-68811E5C0F24}"/>
               </a:ext>
             </a:extLst>
           </p:cNvPr>
@@ -4997,7 +4997,7 @@
           <p:cNvPr id="5" name="TextBox 4">
             <a:extLst>
               <a:ext uri="{FF2B5EF4-FFF2-40B4-BE49-F238E27FC236}">
-                <a16:creationId xmlns:a16="http://schemas.microsoft.com/office/drawing/2014/main" xmlns="" id="{B01A5DE1-1247-401C-BE19-9C17DDCEF486}"/>
+                <a16:creationId xmlns="" xmlns:a16="http://schemas.microsoft.com/office/drawing/2014/main" id="{B01A5DE1-1247-401C-BE19-9C17DDCEF486}"/>
               </a:ext>
             </a:extLst>
           </p:cNvPr>
@@ -5007,7 +5007,7 @@
         <p:spPr>
           <a:xfrm>
             <a:off x="1228578" y="117693"/>
-            <a:ext cx="9734843" cy="6740307"/>
+            <a:ext cx="9734843" cy="6370975"/>
           </a:xfrm>
           <a:prstGeom prst="rect">
             <a:avLst/>
@@ -5169,19 +5169,17 @@
               <a:t>dbms_output.put_line</a:t>
             </a:r>
             <a:r>
-              <a:rPr lang="en-IN" sz="2400" dirty="0"/>
-              <a:t>('Welcome to </a:t>
-            </a:r>
-            <a:r>
-              <a:rPr lang="en-IN" sz="2400" dirty="0" err="1"/>
-              <a:t>GeeksforGeeks</a:t>
-            </a:r>
-            <a:r>
-              <a:rPr lang="en-IN" sz="2400" dirty="0"/>
-              <a:t>');</a:t>
-            </a:r>
-          </a:p>
-          <a:p>
+              <a:rPr lang="en-IN" sz="2400" dirty="0" smtClean="0"/>
+              <a:t>(‘Demo </a:t>
+            </a:r>
+            <a:r>
+              <a:rPr lang="en-IN" sz="2400" smtClean="0"/>
+              <a:t>of named </a:t>
+            </a:r>
+            <a:r>
+              <a:rPr lang="en-IN" sz="2400" dirty="0" smtClean="0"/>
+              <a:t>Exception ');</a:t>
+            </a:r>
             <a:endParaRPr lang="en-IN" sz="2400" dirty="0"/>
           </a:p>
           <a:p>
@@ -5227,7 +5225,7 @@
           <p:cNvPr id="2" name="Title 1">
             <a:extLst>
               <a:ext uri="{FF2B5EF4-FFF2-40B4-BE49-F238E27FC236}">
-                <a16:creationId xmlns:a16="http://schemas.microsoft.com/office/drawing/2014/main" xmlns="" id="{002A06B4-7A88-4EA5-9FA1-BED1102A5521}"/>
+                <a16:creationId xmlns="" xmlns:a16="http://schemas.microsoft.com/office/drawing/2014/main" id="{002A06B4-7A88-4EA5-9FA1-BED1102A5521}"/>
               </a:ext>
             </a:extLst>
           </p:cNvPr>
@@ -5260,7 +5258,7 @@
           <p:cNvPr id="3" name="Content Placeholder 2">
             <a:extLst>
               <a:ext uri="{FF2B5EF4-FFF2-40B4-BE49-F238E27FC236}">
-                <a16:creationId xmlns:a16="http://schemas.microsoft.com/office/drawing/2014/main" xmlns="" id="{D1532173-D42A-4895-A5EE-C5DA893A18C4}"/>
+                <a16:creationId xmlns="" xmlns:a16="http://schemas.microsoft.com/office/drawing/2014/main" id="{D1532173-D42A-4895-A5EE-C5DA893A18C4}"/>
               </a:ext>
             </a:extLst>
           </p:cNvPr>

</xml_diff>